<commit_message>
text removed from Icon
</commit_message>
<xml_diff>
--- a/PIMMS v1.2/Icon/Icon PowerPoint.pptx
+++ b/PIMMS v1.2/Icon/Icon PowerPoint.pptx
@@ -3074,10 +3074,10 @@
         </p:nvGrpSpPr>
         <p:grpSpPr>
           <a:xfrm>
-            <a:off x="-25364" y="0"/>
-            <a:ext cx="9180214" cy="9230952"/>
-            <a:chOff x="-25364" y="0"/>
-            <a:chExt cx="9180214" cy="9230952"/>
+            <a:off x="0" y="0"/>
+            <a:ext cx="9144000" cy="9230952"/>
+            <a:chOff x="0" y="0"/>
+            <a:chExt cx="9144000" cy="9230952"/>
           </a:xfrm>
         </p:grpSpPr>
         <p:pic>
@@ -3426,7 +3426,7 @@
             <a:lstStyle/>
             <a:p>
               <a:pPr algn="ctr"/>
-              <a:endParaRPr lang="en-US"/>
+              <a:endParaRPr lang="en-US" dirty="0"/>
             </a:p>
           </p:txBody>
         </p:sp>
@@ -3636,7 +3636,7 @@
             <a:lstStyle/>
             <a:p>
               <a:pPr algn="ctr"/>
-              <a:endParaRPr lang="en-US"/>
+              <a:endParaRPr lang="en-US" dirty="0"/>
             </a:p>
           </p:txBody>
         </p:sp>
@@ -3740,7 +3740,7 @@
             <a:lstStyle/>
             <a:p>
               <a:pPr algn="ctr"/>
-              <a:endParaRPr lang="en-US"/>
+              <a:endParaRPr lang="en-US" dirty="0"/>
             </a:p>
           </p:txBody>
         </p:sp>
@@ -3789,211 +3789,6 @@
             </a:p>
           </p:txBody>
         </p:sp>
-        <p:grpSp>
-          <p:nvGrpSpPr>
-            <p:cNvPr id="2126" name="Group 2125">
-              <a:extLst>
-                <a:ext uri="{FF2B5EF4-FFF2-40B4-BE49-F238E27FC236}">
-                  <a16:creationId xmlns:a16="http://schemas.microsoft.com/office/drawing/2014/main" id="{42A638D1-CA69-CE3C-EB6C-F31F79A9711B}"/>
-                </a:ext>
-              </a:extLst>
-            </p:cNvPr>
-            <p:cNvGrpSpPr/>
-            <p:nvPr/>
-          </p:nvGrpSpPr>
-          <p:grpSpPr>
-            <a:xfrm>
-              <a:off x="-25364" y="6183086"/>
-              <a:ext cx="9180214" cy="2975406"/>
-              <a:chOff x="-25364" y="6183086"/>
-              <a:chExt cx="9180214" cy="2975406"/>
-            </a:xfrm>
-          </p:grpSpPr>
-          <p:sp>
-            <p:nvSpPr>
-              <p:cNvPr id="2068" name="Rectangle: Rounded Corners 2067">
-                <a:extLst>
-                  <a:ext uri="{FF2B5EF4-FFF2-40B4-BE49-F238E27FC236}">
-                    <a16:creationId xmlns:a16="http://schemas.microsoft.com/office/drawing/2014/main" id="{C38AF637-D192-23CE-2EE8-B66EBABDF57F}"/>
-                  </a:ext>
-                </a:extLst>
-              </p:cNvPr>
-              <p:cNvSpPr/>
-              <p:nvPr/>
-            </p:nvSpPr>
-            <p:spPr>
-              <a:xfrm>
-                <a:off x="6230849" y="6183086"/>
-                <a:ext cx="2924001" cy="2975406"/>
-              </a:xfrm>
-              <a:prstGeom prst="roundRect">
-                <a:avLst/>
-              </a:prstGeom>
-              <a:solidFill>
-                <a:srgbClr val="BA404C"/>
-              </a:solidFill>
-              <a:ln>
-                <a:solidFill>
-                  <a:srgbClr val="842D35"/>
-                </a:solidFill>
-              </a:ln>
-            </p:spPr>
-            <p:style>
-              <a:lnRef idx="2">
-                <a:schemeClr val="accent1">
-                  <a:shade val="15000"/>
-                </a:schemeClr>
-              </a:lnRef>
-              <a:fillRef idx="1">
-                <a:schemeClr val="accent1"/>
-              </a:fillRef>
-              <a:effectRef idx="0">
-                <a:schemeClr val="accent1"/>
-              </a:effectRef>
-              <a:fontRef idx="minor">
-                <a:schemeClr val="lt1"/>
-              </a:fontRef>
-            </p:style>
-            <p:txBody>
-              <a:bodyPr rtlCol="0" anchor="ctr"/>
-              <a:lstStyle/>
-              <a:p>
-                <a:pPr algn="ctr"/>
-                <a:r>
-                  <a:rPr lang="en-US" sz="10000" b="1" i="1" dirty="0">
-                    <a:solidFill>
-                      <a:schemeClr val="bg1"/>
-                    </a:solidFill>
-                    <a:latin typeface="Arial" panose="020B0604020202020204" pitchFamily="34" charset="0"/>
-                    <a:cs typeface="Arial" panose="020B0604020202020204" pitchFamily="34" charset="0"/>
-                  </a:rPr>
-                  <a:t>MS</a:t>
-                </a:r>
-              </a:p>
-            </p:txBody>
-          </p:sp>
-          <p:sp>
-            <p:nvSpPr>
-              <p:cNvPr id="2067" name="Rectangle: Rounded Corners 2066">
-                <a:extLst>
-                  <a:ext uri="{FF2B5EF4-FFF2-40B4-BE49-F238E27FC236}">
-                    <a16:creationId xmlns:a16="http://schemas.microsoft.com/office/drawing/2014/main" id="{D10490E5-03F3-8B8A-EED0-91B01F0EA4C9}"/>
-                  </a:ext>
-                </a:extLst>
-              </p:cNvPr>
-              <p:cNvSpPr/>
-              <p:nvPr/>
-            </p:nvSpPr>
-            <p:spPr>
-              <a:xfrm>
-                <a:off x="3109999" y="6183086"/>
-                <a:ext cx="2924001" cy="2975406"/>
-              </a:xfrm>
-              <a:prstGeom prst="roundRect">
-                <a:avLst/>
-              </a:prstGeom>
-              <a:solidFill>
-                <a:srgbClr val="4F8B55"/>
-              </a:solidFill>
-              <a:ln>
-                <a:solidFill>
-                  <a:srgbClr val="4F8B55"/>
-                </a:solidFill>
-              </a:ln>
-            </p:spPr>
-            <p:style>
-              <a:lnRef idx="2">
-                <a:schemeClr val="accent1">
-                  <a:shade val="15000"/>
-                </a:schemeClr>
-              </a:lnRef>
-              <a:fillRef idx="1">
-                <a:schemeClr val="accent1"/>
-              </a:fillRef>
-              <a:effectRef idx="0">
-                <a:schemeClr val="accent1"/>
-              </a:effectRef>
-              <a:fontRef idx="minor">
-                <a:schemeClr val="lt1"/>
-              </a:fontRef>
-            </p:style>
-            <p:txBody>
-              <a:bodyPr rtlCol="0" anchor="ctr"/>
-              <a:lstStyle/>
-              <a:p>
-                <a:pPr algn="ctr"/>
-                <a:r>
-                  <a:rPr lang="en-US" sz="10000" b="1" i="1" dirty="0">
-                    <a:solidFill>
-                      <a:schemeClr val="bg1"/>
-                    </a:solidFill>
-                    <a:latin typeface="Arial" panose="020B0604020202020204" pitchFamily="34" charset="0"/>
-                    <a:cs typeface="Arial" panose="020B0604020202020204" pitchFamily="34" charset="0"/>
-                  </a:rPr>
-                  <a:t>IM</a:t>
-                </a:r>
-              </a:p>
-            </p:txBody>
-          </p:sp>
-          <p:sp>
-            <p:nvSpPr>
-              <p:cNvPr id="2110" name="Rectangle: Rounded Corners 2109">
-                <a:extLst>
-                  <a:ext uri="{FF2B5EF4-FFF2-40B4-BE49-F238E27FC236}">
-                    <a16:creationId xmlns:a16="http://schemas.microsoft.com/office/drawing/2014/main" id="{C14D84EC-68E8-510C-F794-621575836238}"/>
-                  </a:ext>
-                </a:extLst>
-              </p:cNvPr>
-              <p:cNvSpPr/>
-              <p:nvPr/>
-            </p:nvSpPr>
-            <p:spPr>
-              <a:xfrm>
-                <a:off x="-25364" y="6183086"/>
-                <a:ext cx="2924001" cy="2975406"/>
-              </a:xfrm>
-              <a:prstGeom prst="roundRect">
-                <a:avLst/>
-              </a:prstGeom>
-              <a:solidFill>
-                <a:srgbClr val="BCCA78"/>
-              </a:solidFill>
-            </p:spPr>
-            <p:style>
-              <a:lnRef idx="2">
-                <a:schemeClr val="accent1">
-                  <a:shade val="15000"/>
-                </a:schemeClr>
-              </a:lnRef>
-              <a:fillRef idx="1">
-                <a:schemeClr val="accent1"/>
-              </a:fillRef>
-              <a:effectRef idx="0">
-                <a:schemeClr val="accent1"/>
-              </a:effectRef>
-              <a:fontRef idx="minor">
-                <a:schemeClr val="lt1"/>
-              </a:fontRef>
-            </p:style>
-            <p:txBody>
-              <a:bodyPr rtlCol="0" anchor="ctr"/>
-              <a:lstStyle/>
-              <a:p>
-                <a:pPr algn="ctr"/>
-                <a:r>
-                  <a:rPr lang="en-US" sz="10000" b="1" i="1" dirty="0">
-                    <a:solidFill>
-                      <a:schemeClr val="bg1"/>
-                    </a:solidFill>
-                    <a:latin typeface="Arial" panose="020B0604020202020204" pitchFamily="34" charset="0"/>
-                    <a:cs typeface="Arial" panose="020B0604020202020204" pitchFamily="34" charset="0"/>
-                  </a:rPr>
-                  <a:t>P</a:t>
-                </a:r>
-              </a:p>
-            </p:txBody>
-          </p:sp>
-        </p:grpSp>
       </p:grpSp>
     </p:spTree>
     <p:extLst>

</xml_diff>